<commit_message>
docs: add Loom demo walkthrough link to README and presentation
</commit_message>
<xml_diff>
--- a/ExpensePilot_DevOps_Capstone.pptx
+++ b/ExpensePilot_DevOps_Capstone.pptx
@@ -119,30 +119,30 @@
   <p:extLst>
     <p:ext uri="{521415D9-36F7-43E2-AB2F-B90AF26B5E84}">
       <p14:sectionLst xmlns:p14="http://schemas.microsoft.com/office/powerpoint/2010/main">
-        <p14:section name="Intro" id="{79c61ff4-c89a-a9ad-6e41-bf2d2ec19946}">
+        <p14:section name="Intro" id="{8edd75cf-1314-1db3-5d1f-7df6f16af89f}">
           <p14:sldIdLst>
             <p14:sldId id="256"/>
           </p14:sldIdLst>
         </p14:section>
-        <p14:section name="Architecture" id="{d24cee12-5d26-ee17-61c6-57e82e8cc580}">
+        <p14:section name="Architecture" id="{cdf2f512-afbd-0c35-a906-643d6b3c4e59}">
           <p14:sldIdLst>
             <p14:sldId id="257"/>
           </p14:sldIdLst>
         </p14:section>
-        <p14:section name="Build" id="{a6c1132c-a7d2-67b8-c47b-7dfd2feba772}">
+        <p14:section name="Build" id="{643181c9-1bdf-7ecf-1b4d-81ae1c4af883}">
           <p14:sldIdLst>
             <p14:sldId id="258"/>
             <p14:sldId id="259"/>
           </p14:sldIdLst>
         </p14:section>
-        <p14:section name="Ship" id="{8360f964-ac5e-014a-a1a9-dfbd4c589e08}">
+        <p14:section name="Ship" id="{4ae10103-f3e8-3997-0ff6-2cf20b13a501}">
           <p14:sldIdLst>
             <p14:sldId id="260"/>
             <p14:sldId id="261"/>
             <p14:sldId id="262"/>
           </p14:sldIdLst>
         </p14:section>
-        <p14:section name="Run" id="{b642f794-5980-18a0-bcce-0f6c9ca93f7d}">
+        <p14:section name="Run" id="{66de9d24-0710-ce06-495d-f0f2f7b5164f}">
           <p14:sldIdLst>
             <p14:sldId id="263"/>
             <p14:sldId id="264"/>
@@ -150,12 +150,12 @@
             <p14:sldId id="266"/>
           </p14:sldIdLst>
         </p14:section>
-        <p14:section name="Extras" id="{f915dbd5-e8c4-1a68-550d-e220a7f5de40}">
+        <p14:section name="Extras" id="{a1e829b8-b5f9-f135-421e-8d0630b16b9b}">
           <p14:sldIdLst>
             <p14:sldId id="267"/>
           </p14:sldIdLst>
         </p14:section>
-        <p14:section name="Demo" id="{69d39b2d-a93f-9c9c-2d7b-d5be1fe4e5fc}">
+        <p14:section name="Demo" id="{0257b11f-96a2-718a-b6b6-cd44f079937f}">
           <p14:sldIdLst>
             <p14:sldId id="268"/>
           </p14:sldIdLst>
@@ -916,7 +916,7 @@
           <a:p>
             <a:r>
               <a:rPr lang="en-US" dirty="0"/>
-              <a:t>For the demo I'll change the heading on the dashboard, commit and push. We watch the Actions run go green and the new SHA tag appear in GHCR. Then I roll it out with helm upgrade using that tag, and kubectl rollout status shows the new pods replacing the old ones. Refreshing expensepilot.local shows the change. The README in the repo has all of these steps and screenshots. Thank you.</a:t>
+              <a:t>For the demo I'll change the heading on the dashboard, commit and push. We watch the Actions run go green and the new SHA tag appear in GHCR. Then I roll it out with helm upgrade using that tag, and kubectl rollout status shows the new pods replacing the old ones. Refreshing expensepilot.local shows the change. If anything goes wrong live, the same flow is in the recorded Loom walkthrough linked on this slide. The README in the repo has all of these steps and screenshots. Thank you.</a:t>
             </a:r>
             <a:endParaRPr lang="en-US" dirty="0"/>
           </a:p>
@@ -1620,7 +1620,7 @@
           <a:p>
             <a:r>
               <a:rPr lang="en-US" dirty="0"/>
-              <a:t>This is the cluster Terraform created, showing Active on Kubernetes 1.31 in the Mumbai region in the AWS console. Once I had the evidence I ran terraform destroy. It planned 56 resources to destroy, the same 56 that apply created, including the VPC and the EKS cluster, and after confirming with yes it finished with Destroy complete, 56 destroyed. The VPC is the last thing removed. There are no running costs left on the account.</a:t>
+              <a:t>In the AWS console, the cluster Terraform created is Active on Kubernetes 1.31 in Mumbai, and expensepilot-vpc shows up with the 10.20.0.0/16 CIDR from the Terraform code. Once I had the evidence I ran terraform destroy. It planned 56 resources to destroy, the same 56 that apply created, including the VPC and the EKS cluster, and after confirming with yes it finished with Destroy complete, 56 destroyed. The VPC is the last thing removed. There are no running costs left on the account.</a:t>
             </a:r>
             <a:endParaRPr lang="en-US" dirty="0"/>
           </a:p>
@@ -5549,8 +5549,8 @@
         </p:nvSpPr>
         <p:spPr>
           <a:xfrm>
-            <a:off x="6035040" y="5623560"/>
-            <a:ext cx="5605272" cy="502920"/>
+            <a:off x="6035040" y="5193792"/>
+            <a:ext cx="5605272" cy="365760"/>
           </a:xfrm>
           <a:prstGeom prst="rect">
             <a:avLst/>
@@ -5566,21 +5566,18 @@
               <a:buNone/>
             </a:pPr>
             <a:r>
-              <a:rPr lang="en-US" sz="2000" b="1" dirty="0">
-                <a:solidFill>
-                  <a:schemeClr val="tx1"/>
-                </a:solidFill>
-                <a:latin typeface="Arial" pitchFamily="34" charset="0"/>
-                <a:ea typeface="Arial" pitchFamily="34" charset="-122"/>
-                <a:cs typeface="Arial" pitchFamily="34" charset="-120"/>
-              </a:rPr>
-              <a:t>Thanks!  </a:t>
-            </a:r>
-            <a:pPr indent="0" marL="0">
-              <a:buNone/>
-            </a:pPr>
-            <a:r>
-              <a:rPr lang="en-US" sz="1200" u="sng" dirty="0">
+              <a:rPr lang="en-US" sz="1400" b="1" dirty="0">
+                <a:solidFill>
+                  <a:schemeClr val="accent1"/>
+                </a:solidFill>
+              </a:rPr>
+              <a:t>Recorded walkthrough:  </a:t>
+            </a:r>
+            <a:pPr indent="0" marL="0">
+              <a:buNone/>
+            </a:pPr>
+            <a:r>
+              <a:rPr lang="en-US" sz="1300" u="sng" dirty="0">
                 <a:solidFill>
                   <a:schemeClr val="accent4"/>
                 </a:solidFill>
@@ -5588,6 +5585,66 @@
                 <a:ea typeface="Courier New" pitchFamily="34" charset="-122"/>
                 <a:cs typeface="Courier New" pitchFamily="34" charset="-120"/>
                 <a:hlinkClick r:id="rId2" invalidUrl="" action="" tgtFrame="" tooltip="" history="1" highlightClick="0" endSnd="0">
+                  <a:extLst>
+                    <a:ext uri="{A12FA001-AC4F-418D-AE19-62706E023703}">
+                      <ahyp:hlinkClr xmlns:ahyp="http://schemas.microsoft.com/office/drawing/2018/hyperlinkcolor" val="tx"/>
+                    </a:ext>
+                  </a:extLst>
+                </a:hlinkClick>
+              </a:rPr>
+              <a:t>watch the demo on Loom</a:t>
+            </a:r>
+            <a:endParaRPr lang="en-US" sz="1400" dirty="0"/>
+          </a:p>
+        </p:txBody>
+      </p:sp>
+      <p:sp>
+        <p:nvSpPr>
+          <p:cNvPr id="19" name="Text 16"/>
+          <p:cNvSpPr txBox="1"/>
+          <p:nvPr/>
+        </p:nvSpPr>
+        <p:spPr>
+          <a:xfrm>
+            <a:off x="6035040" y="5623560"/>
+            <a:ext cx="5605272" cy="502920"/>
+          </a:xfrm>
+          <a:prstGeom prst="rect">
+            <a:avLst/>
+          </a:prstGeom>
+          <a:noFill/>
+          <a:ln/>
+        </p:spPr>
+        <p:txBody>
+          <a:bodyPr wrap="square" lIns="0" tIns="0" rIns="0" bIns="0" rtlCol="0" anchor="ctr"/>
+          <a:lstStyle/>
+          <a:p>
+            <a:pPr indent="0" marL="0">
+              <a:buNone/>
+            </a:pPr>
+            <a:r>
+              <a:rPr lang="en-US" sz="2000" b="1" dirty="0">
+                <a:solidFill>
+                  <a:schemeClr val="tx1"/>
+                </a:solidFill>
+                <a:latin typeface="Arial" pitchFamily="34" charset="0"/>
+                <a:ea typeface="Arial" pitchFamily="34" charset="-122"/>
+                <a:cs typeface="Arial" pitchFamily="34" charset="-120"/>
+              </a:rPr>
+              <a:t>Thanks!  </a:t>
+            </a:r>
+            <a:pPr indent="0" marL="0">
+              <a:buNone/>
+            </a:pPr>
+            <a:r>
+              <a:rPr lang="en-US" sz="1200" u="sng" dirty="0">
+                <a:solidFill>
+                  <a:schemeClr val="accent4"/>
+                </a:solidFill>
+                <a:latin typeface="Courier New" pitchFamily="34" charset="0"/>
+                <a:ea typeface="Courier New" pitchFamily="34" charset="-122"/>
+                <a:cs typeface="Courier New" pitchFamily="34" charset="-120"/>
+                <a:hlinkClick r:id="rId3" invalidUrl="" action="" tgtFrame="" tooltip="" history="1" highlightClick="0" endSnd="0">
                   <a:extLst>
                     <a:ext uri="{A12FA001-AC4F-418D-AE19-62706E023703}">
                       <ahyp:hlinkClr xmlns:ahyp="http://schemas.microsoft.com/office/drawing/2018/hyperlinkcolor" val="tx"/>
@@ -11781,8 +11838,8 @@
         </p:nvSpPr>
         <p:spPr>
           <a:xfrm>
-            <a:off x="548640" y="1234440"/>
-            <a:ext cx="7315200" cy="256032"/>
+            <a:off x="548640" y="1280160"/>
+            <a:ext cx="5394960" cy="256032"/>
           </a:xfrm>
           <a:prstGeom prst="rect">
             <a:avLst/>
@@ -11806,7 +11863,7 @@
                 <a:ea typeface="Courier New" pitchFamily="34" charset="-122"/>
                 <a:cs typeface="Courier New" pitchFamily="34" charset="-120"/>
               </a:rPr>
-              <a:t>aws console: EKS clusters, Asia Pacific (Mumbai)</a:t>
+              <a:t>aws console: EKS cluster, ap-south-1</a:t>
             </a:r>
             <a:endParaRPr lang="en-US" sz="1100" dirty="0"/>
           </a:p>
@@ -11820,8 +11877,8 @@
         </p:nvSpPr>
         <p:spPr>
           <a:xfrm>
-            <a:off x="521208" y="1527048"/>
-            <a:ext cx="11146536" cy="2223286"/>
+            <a:off x="521208" y="1572768"/>
+            <a:ext cx="5449824" cy="1109579"/>
           </a:xfrm>
           <a:prstGeom prst="rect">
             <a:avLst/>
@@ -11853,8 +11910,8 @@
         </p:blipFill>
         <p:spPr>
           <a:xfrm>
-            <a:off x="548640" y="1554480"/>
-            <a:ext cx="11091672" cy="2168422"/>
+            <a:off x="548640" y="1600200"/>
+            <a:ext cx="5394960" cy="1054715"/>
           </a:xfrm>
           <a:prstGeom prst="rect">
             <a:avLst/>
@@ -11869,8 +11926,8 @@
         </p:nvSpPr>
         <p:spPr>
           <a:xfrm>
-            <a:off x="548640" y="3886200"/>
-            <a:ext cx="5486400" cy="256032"/>
+            <a:off x="6245352" y="1280160"/>
+            <a:ext cx="5394960" cy="256032"/>
           </a:xfrm>
           <a:prstGeom prst="rect">
             <a:avLst/>
@@ -11894,7 +11951,7 @@
                 <a:ea typeface="Courier New" pitchFamily="34" charset="-122"/>
                 <a:cs typeface="Courier New" pitchFamily="34" charset="-120"/>
               </a:rPr>
-              <a:t>$ terraform destroy</a:t>
+              <a:t>aws console: expensepilot-vpc, 10.20.0.0/16</a:t>
             </a:r>
             <a:endParaRPr lang="en-US" sz="1100" dirty="0"/>
           </a:p>
@@ -11902,14 +11959,14 @@
       </p:sp>
       <p:sp>
         <p:nvSpPr>
-          <p:cNvPr id="7" name="frame destroy.jpg"/>
+          <p:cNvPr id="7" name="frame vpc.jpg"/>
           <p:cNvSpPr/>
           <p:nvPr/>
         </p:nvSpPr>
         <p:spPr>
           <a:xfrm>
-            <a:off x="521208" y="4178808"/>
-            <a:ext cx="5815584" cy="1943100"/>
+            <a:off x="6217920" y="1572768"/>
+            <a:ext cx="5449824" cy="1166825"/>
           </a:xfrm>
           <a:prstGeom prst="rect">
             <a:avLst/>
@@ -11927,7 +11984,7 @@
       </p:sp>
       <p:pic>
         <p:nvPicPr>
-          <p:cNvPr id="8" name="Image 1" descr="destroy.jpg">    </p:cNvPr>
+          <p:cNvPr id="8" name="Image 1" descr="vpc.jpg">    </p:cNvPr>
           <p:cNvPicPr>
             <a:picLocks noChangeAspect="1"/>
           </p:cNvPicPr>
@@ -11941,8 +11998,8 @@
         </p:blipFill>
         <p:spPr>
           <a:xfrm>
-            <a:off x="548640" y="4206240"/>
-            <a:ext cx="5760720" cy="1888236"/>
+            <a:off x="6245352" y="1600200"/>
+            <a:ext cx="5394960" cy="1111961"/>
           </a:xfrm>
           <a:prstGeom prst="rect">
             <a:avLst/>
@@ -11957,58 +12014,8 @@
         </p:nvSpPr>
         <p:spPr>
           <a:xfrm>
-            <a:off x="6720840" y="3886200"/>
-            <a:ext cx="4919472" cy="868680"/>
-          </a:xfrm>
-          <a:prstGeom prst="rect">
-            <a:avLst/>
-          </a:prstGeom>
-          <a:noFill/>
-          <a:ln/>
-        </p:spPr>
-        <p:txBody>
-          <a:bodyPr wrap="square" lIns="0" tIns="0" rIns="0" bIns="0" rtlCol="0" anchor="ctr"/>
-          <a:lstStyle/>
-          <a:p>
-            <a:pPr indent="0" marL="0">
-              <a:buNone/>
-            </a:pPr>
-            <a:r>
-              <a:rPr lang="en-US" sz="5400" b="1" dirty="0">
-                <a:solidFill>
-                  <a:schemeClr val="accent5"/>
-                </a:solidFill>
-                <a:latin typeface="Arial" pitchFamily="34" charset="0"/>
-                <a:ea typeface="Arial" pitchFamily="34" charset="-122"/>
-                <a:cs typeface="Arial" pitchFamily="34" charset="-120"/>
-              </a:rPr>
-              <a:t>56</a:t>
-            </a:r>
-            <a:pPr indent="0" marL="0">
-              <a:buNone/>
-            </a:pPr>
-            <a:r>
-              <a:rPr lang="en-US" sz="1800" dirty="0">
-                <a:solidFill>
-                  <a:schemeClr val="tx2"/>
-                </a:solidFill>
-              </a:rPr>
-              <a:t>  planned, 56 destroyed</a:t>
-            </a:r>
-            <a:endParaRPr lang="en-US" sz="5400" dirty="0"/>
-          </a:p>
-        </p:txBody>
-      </p:sp>
-      <p:sp>
-        <p:nvSpPr>
-          <p:cNvPr id="10" name="Text 6"/>
-          <p:cNvSpPr txBox="1"/>
-          <p:nvPr/>
-        </p:nvSpPr>
-        <p:spPr>
-          <a:xfrm>
-            <a:off x="6720840" y="4846320"/>
-            <a:ext cx="4919472" cy="256032"/>
+            <a:off x="548640" y="3383280"/>
+            <a:ext cx="5486400" cy="256032"/>
           </a:xfrm>
           <a:prstGeom prst="rect">
             <a:avLst/>
@@ -12032,7 +12039,7 @@
                 <a:ea typeface="Courier New" pitchFamily="34" charset="-122"/>
                 <a:cs typeface="Courier New" pitchFamily="34" charset="-120"/>
               </a:rPr>
-              <a:t>destroy finished, VPC removed last</a:t>
+              <a:t>$ terraform destroy</a:t>
             </a:r>
             <a:endParaRPr lang="en-US" sz="1100" dirty="0"/>
           </a:p>
@@ -12040,14 +12047,14 @@
       </p:sp>
       <p:sp>
         <p:nvSpPr>
-          <p:cNvPr id="11" name="frame destroyed.jpg"/>
+          <p:cNvPr id="10" name="frame destroy.jpg"/>
           <p:cNvSpPr/>
           <p:nvPr/>
         </p:nvSpPr>
         <p:spPr>
           <a:xfrm>
-            <a:off x="6693408" y="5138928"/>
-            <a:ext cx="4974336" cy="645201"/>
+            <a:off x="521208" y="3675888"/>
+            <a:ext cx="6455664" cy="2152904"/>
           </a:xfrm>
           <a:prstGeom prst="rect">
             <a:avLst/>
@@ -12065,7 +12072,7 @@
       </p:sp>
       <p:pic>
         <p:nvPicPr>
-          <p:cNvPr id="12" name="Image 2" descr="destroyed.jpg">    </p:cNvPr>
+          <p:cNvPr id="11" name="Image 2" descr="destroy.jpg">    </p:cNvPr>
           <p:cNvPicPr>
             <a:picLocks noChangeAspect="1"/>
           </p:cNvPicPr>
@@ -12079,8 +12086,8 @@
         </p:blipFill>
         <p:spPr>
           <a:xfrm>
-            <a:off x="6720840" y="5166360"/>
-            <a:ext cx="4919472" cy="590337"/>
+            <a:off x="548640" y="3703320"/>
+            <a:ext cx="6400800" cy="2098040"/>
           </a:xfrm>
           <a:prstGeom prst="rect">
             <a:avLst/>
@@ -12089,14 +12096,152 @@
       </p:pic>
       <p:sp>
         <p:nvSpPr>
+          <p:cNvPr id="12" name="Text 7"/>
+          <p:cNvSpPr txBox="1"/>
+          <p:nvPr/>
+        </p:nvSpPr>
+        <p:spPr>
+          <a:xfrm>
+            <a:off x="7315200" y="3383280"/>
+            <a:ext cx="4325112" cy="868680"/>
+          </a:xfrm>
+          <a:prstGeom prst="rect">
+            <a:avLst/>
+          </a:prstGeom>
+          <a:noFill/>
+          <a:ln/>
+        </p:spPr>
+        <p:txBody>
+          <a:bodyPr wrap="square" lIns="0" tIns="0" rIns="0" bIns="0" rtlCol="0" anchor="ctr"/>
+          <a:lstStyle/>
+          <a:p>
+            <a:pPr indent="0" marL="0">
+              <a:buNone/>
+            </a:pPr>
+            <a:r>
+              <a:rPr lang="en-US" sz="5400" b="1" dirty="0">
+                <a:solidFill>
+                  <a:schemeClr val="accent5"/>
+                </a:solidFill>
+                <a:latin typeface="Arial" pitchFamily="34" charset="0"/>
+                <a:ea typeface="Arial" pitchFamily="34" charset="-122"/>
+                <a:cs typeface="Arial" pitchFamily="34" charset="-120"/>
+              </a:rPr>
+              <a:t>56</a:t>
+            </a:r>
+            <a:pPr indent="0" marL="0">
+              <a:buNone/>
+            </a:pPr>
+            <a:r>
+              <a:rPr lang="en-US" sz="1800" dirty="0">
+                <a:solidFill>
+                  <a:schemeClr val="tx2"/>
+                </a:solidFill>
+              </a:rPr>
+              <a:t>  destroyed</a:t>
+            </a:r>
+            <a:endParaRPr lang="en-US" sz="5400" dirty="0"/>
+          </a:p>
+        </p:txBody>
+      </p:sp>
+      <p:sp>
+        <p:nvSpPr>
           <p:cNvPr id="13" name="Text 8"/>
           <p:cNvSpPr txBox="1"/>
           <p:nvPr/>
         </p:nvSpPr>
         <p:spPr>
           <a:xfrm>
-            <a:off x="6720840" y="5897880"/>
-            <a:ext cx="4919472" cy="320040"/>
+            <a:off x="7315200" y="4434840"/>
+            <a:ext cx="4325112" cy="256032"/>
+          </a:xfrm>
+          <a:prstGeom prst="rect">
+            <a:avLst/>
+          </a:prstGeom>
+          <a:noFill/>
+          <a:ln/>
+        </p:spPr>
+        <p:txBody>
+          <a:bodyPr wrap="square" lIns="0" tIns="0" rIns="0" bIns="0" rtlCol="0" anchor="ctr"/>
+          <a:lstStyle/>
+          <a:p>
+            <a:pPr indent="0" marL="0">
+              <a:buNone/>
+            </a:pPr>
+            <a:r>
+              <a:rPr lang="en-US" sz="1100" dirty="0">
+                <a:solidFill>
+                  <a:schemeClr val="tx2"/>
+                </a:solidFill>
+                <a:latin typeface="Courier New" pitchFamily="34" charset="0"/>
+                <a:ea typeface="Courier New" pitchFamily="34" charset="-122"/>
+                <a:cs typeface="Courier New" pitchFamily="34" charset="-120"/>
+              </a:rPr>
+              <a:t>destroy complete, VPC removed last</a:t>
+            </a:r>
+            <a:endParaRPr lang="en-US" sz="1100" dirty="0"/>
+          </a:p>
+        </p:txBody>
+      </p:sp>
+      <p:sp>
+        <p:nvSpPr>
+          <p:cNvPr id="14" name="frame destroyed.jpg"/>
+          <p:cNvSpPr/>
+          <p:nvPr/>
+        </p:nvSpPr>
+        <p:spPr>
+          <a:xfrm>
+            <a:off x="7287768" y="4727448"/>
+            <a:ext cx="4379976" cy="573877"/>
+          </a:xfrm>
+          <a:prstGeom prst="rect">
+            <a:avLst/>
+          </a:prstGeom>
+          <a:solidFill>
+            <a:schemeClr val="accent3"/>
+          </a:solidFill>
+          <a:ln w="9525">
+            <a:solidFill>
+              <a:schemeClr val="accent3"/>
+            </a:solidFill>
+            <a:prstDash val="solid"/>
+          </a:ln>
+        </p:spPr>
+      </p:sp>
+      <p:pic>
+        <p:nvPicPr>
+          <p:cNvPr id="15" name="Image 3" descr="destroyed.jpg">    </p:cNvPr>
+          <p:cNvPicPr>
+            <a:picLocks noChangeAspect="1"/>
+          </p:cNvPicPr>
+          <p:nvPr/>
+        </p:nvPicPr>
+        <p:blipFill>
+          <a:blip r:embed="rId4"/>
+          <a:stretch>
+            <a:fillRect/>
+          </a:stretch>
+        </p:blipFill>
+        <p:spPr>
+          <a:xfrm>
+            <a:off x="7315200" y="4754880"/>
+            <a:ext cx="4325112" cy="519013"/>
+          </a:xfrm>
+          <a:prstGeom prst="rect">
+            <a:avLst/>
+          </a:prstGeom>
+        </p:spPr>
+      </p:pic>
+      <p:sp>
+        <p:nvSpPr>
+          <p:cNvPr id="16" name="Text 10"/>
+          <p:cNvSpPr txBox="1"/>
+          <p:nvPr/>
+        </p:nvSpPr>
+        <p:spPr>
+          <a:xfrm>
+            <a:off x="7315200" y="5486400"/>
+            <a:ext cx="4325112" cy="640080"/>
           </a:xfrm>
           <a:prstGeom prst="rect">
             <a:avLst/>

</xml_diff>